<commit_message>
fix(pptx): complete character-property inheritance and no-fill decoration
Merge CT_TextCharacterProperties and direct child attributes through master,
layout, list, paragraph, and run levels. Keep break formatting and
end-paragraph insertion state distinct; preserve independent outlines and
underlines when glyph fill is noFill in flat and warped text.

ECMA-376 Part 1 sections 21.1.2.2.1, 21.1.2.2.2, 21.1.2.3.9 and 21.1.2.4.
Verified with parser, browser, worker, API, type, lint and full PPTX self-VRT
against Office references.

Co-Authored-By: Codex gpt-6-sol <noreply@openai.com>
Co-Authored-By: Claude Opus 5.5 <noreply@anthropic.com>
</commit_message>
<xml_diff>
--- a/tests/inheritance/fixtures/pptx-run-inheritance.pptx
+++ b/tests/inheritance/fixtures/pptx-run-inheritance.pptx
@@ -3,13 +3,15 @@
 <p:presentation xmlns:p="http://schemas.openxmlformats.org/presentationml/2006/main" xmlns:r="http://schemas.openxmlformats.org/officeDocument/2006/relationships">
   <p:sldIdLst>
     <p:sldId id="256" r:id="rId1"/>
+    <p:sldId id="257" r:id="rId2"/>
+    <p:sldId id="258" r:id="rId3"/>
   </p:sldIdLst>
   <p:sldSz cx="12192000" cy="6858000"/>
 </p:presentation>
 </file>
 
 <file path=ppt/slides/slide1.xml><?xml version="1.0" encoding="utf-8"?>
-<p:sld xmlns:p="http://schemas.openxmlformats.org/presentationml/2006/main" xmlns:a="http://schemas.openxmlformats.org/drawingml/2006/main">
+<p:sld xmlns:p="http://schemas.openxmlformats.org/presentationml/2006/main" xmlns:a="http://schemas.openxmlformats.org/drawingml/2006/main" xmlns:r="http://schemas.openxmlformats.org/officeDocument/2006/relationships">
   <p:cSld>
     <p:spTree>
       <p:nvGrpSpPr>
@@ -38,11 +40,14 @@
           <a:bodyPr wrap="none" lIns="0" rIns="0" tIns="0" bIns="0"/>
           <a:lstStyle>
             <a:lvl1pPr>
-              <a:defRPr sz="4800">
-                <a:solidFill>
-                  <a:srgbClr val="D21D54"/>
-                </a:solidFill>
-                <a:latin typeface="Arial"/>
+              <a:defRPr sz="4800" kumimoji="1" lang="ja-JP" altLang="en-US" kern="1200" cap="none" normalizeH="1" noProof="1" smtClean="0" smtId="17" bmk="sample">
+                <a:solidFill>
+                  <a:srgbClr val="D21D54"/>
+                </a:solidFill>
+                <a:latin typeface="Arial" panose="020B0604020202020204"/>
+                <a:cs typeface="Amiri"/>
+                <a:sym typeface="Symbol"/>
+                <a:hlinkMouseOver r:id="rId4" tooltip="hover"/>
               </a:defRPr>
             </a:lvl1pPr>
           </a:lstStyle>
@@ -77,11 +82,14 @@
           <a:bodyPr wrap="none" lIns="0" rIns="0" tIns="0" bIns="0"/>
           <a:lstStyle>
             <a:lvl1pPr>
-              <a:defRPr sz="4800">
-                <a:solidFill>
-                  <a:srgbClr val="D21D54"/>
-                </a:solidFill>
-                <a:latin typeface="Arial"/>
+              <a:defRPr sz="4800" kumimoji="1" lang="ja-JP" altLang="en-US" kern="1200" cap="none" normalizeH="1" noProof="1" smtClean="0" smtId="17" bmk="sample">
+                <a:solidFill>
+                  <a:srgbClr val="D21D54"/>
+                </a:solidFill>
+                <a:latin typeface="Arial" panose="020B0604020202020204"/>
+                <a:cs typeface="Amiri"/>
+                <a:sym typeface="Symbol"/>
+                <a:hlinkMouseOver r:id="rId4" tooltip="hover"/>
               </a:defRPr>
             </a:lvl1pPr>
           </a:lstStyle>
@@ -116,11 +124,14 @@
           <a:bodyPr wrap="none" lIns="0" rIns="0" tIns="0" bIns="0"/>
           <a:lstStyle>
             <a:lvl1pPr>
-              <a:defRPr sz="4800">
-                <a:solidFill>
-                  <a:srgbClr val="D21D54"/>
-                </a:solidFill>
-                <a:latin typeface="Arial"/>
+              <a:defRPr sz="4800" kumimoji="1" lang="ja-JP" altLang="en-US" kern="1200" cap="none" normalizeH="1" noProof="1" smtClean="0" smtId="17" bmk="sample">
+                <a:solidFill>
+                  <a:srgbClr val="D21D54"/>
+                </a:solidFill>
+                <a:latin typeface="Arial" panose="020B0604020202020204"/>
+                <a:cs typeface="Amiri"/>
+                <a:sym typeface="Symbol"/>
+                <a:hlinkMouseOver r:id="rId4" tooltip="hover"/>
               </a:defRPr>
             </a:lvl1pPr>
           </a:lstStyle>
@@ -140,6 +151,408 @@
           </a:p>
         </p:txBody>
       </p:sp>
+      <p:sp>
+        <p:nvSpPr>
+          <p:cNvPr id="5" name="Inheritance 5"/>
+          <p:cNvSpPr txBox="1"/>
+          <p:nvPr/>
+        </p:nvSpPr>
+        <p:spPr>
+          <a:xfrm>
+            <a:off x="600000" y="5550000"/>
+            <a:ext cx="9000000" cy="1300000"/>
+          </a:xfrm>
+          <a:prstGeom prst="rect">
+            <a:avLst/>
+          </a:prstGeom>
+          <a:noFill/>
+        </p:spPr>
+        <p:txBody>
+          <a:bodyPr wrap="none" lIns="0" rIns="0" tIns="0" bIns="0"/>
+          <a:lstStyle>
+            <a:lvl1pPr>
+              <a:defRPr sz="4800" kumimoji="1" lang="ja-JP" altLang="en-US" kern="1200" cap="none" normalizeH="1" noProof="1" smtClean="0" smtId="17" bmk="sample">
+                <a:solidFill>
+                  <a:srgbClr val="D21D54"/>
+                </a:solidFill>
+                <a:latin typeface="Arial" panose="020B0604020202020204"/>
+                <a:cs typeface="Amiri"/>
+                <a:sym typeface="Symbol"/>
+                <a:hlinkMouseOver r:id="rId4" tooltip="hover"/>
+              </a:defRPr>
+            </a:lvl1pPr>
+          </a:lstStyle>
+          <a:p>
+            <a:pPr>
+              <a:defRPr b="1"/>
+            </a:pPr>
+            <a:r>
+              <a:rPr u="sng">
+                <a:ln w="63500">
+                  <a:solidFill>
+                    <a:srgbClr val="008844"/>
+                  </a:solidFill>
+                </a:ln>
+                <a:noFill/>
+                <a:uFill>
+                  <a:pattFill prst="pct50">
+                    <a:fgClr>
+                      <a:srgbClr val="0033EE"/>
+                    </a:fgClr>
+                    <a:bgClr>
+                      <a:srgbClr val="FFDD00"/>
+                    </a:bgClr>
+                  </a:pattFill>
+                </a:uFill>
+              </a:rPr>
+              <a:t>OUTLINE AND UNDERLINE</a:t>
+            </a:r>
+          </a:p>
+        </p:txBody>
+      </p:sp>
+    </p:spTree>
+  </p:cSld>
+</p:sld>
+</file>
+
+<file path=ppt/slides/slide2.xml><?xml version="1.0" encoding="utf-8"?>
+<p:sld xmlns:p="http://schemas.openxmlformats.org/presentationml/2006/main" xmlns:a="http://schemas.openxmlformats.org/drawingml/2006/main" xmlns:r="http://schemas.openxmlformats.org/officeDocument/2006/relationships">
+  <p:cSld>
+    <p:spTree>
+      <p:nvGrpSpPr>
+        <p:cNvPr id="1" name=""/>
+        <p:cNvGrpSpPr/>
+        <p:nvPr/>
+      </p:nvGrpSpPr>
+      <p:grpSpPr/>
+      <p:sp>
+        <p:nvSpPr>
+          <p:cNvPr id="2" name="Inheritance 2"/>
+          <p:cNvSpPr txBox="1"/>
+          <p:nvPr/>
+        </p:nvSpPr>
+        <p:spPr>
+          <a:xfrm>
+            <a:off x="600000" y="500000"/>
+            <a:ext cx="9000000" cy="1300000"/>
+          </a:xfrm>
+          <a:prstGeom prst="rect">
+            <a:avLst/>
+          </a:prstGeom>
+          <a:noFill/>
+        </p:spPr>
+        <p:txBody>
+          <a:bodyPr wrap="none" lIns="0" rIns="0" tIns="0" bIns="0">
+            <a:prstTxWarp prst="textArchUp">
+              <a:avLst/>
+            </a:prstTxWarp>
+          </a:bodyPr>
+          <a:lstStyle>
+            <a:lvl1pPr>
+              <a:defRPr sz="4800" kumimoji="1" lang="ja-JP" altLang="en-US" kern="1200" cap="none" normalizeH="1" noProof="1" smtClean="0" smtId="17" bmk="sample">
+                <a:solidFill>
+                  <a:srgbClr val="D21D54"/>
+                </a:solidFill>
+                <a:latin typeface="Arial" panose="020B0604020202020204"/>
+                <a:cs typeface="Amiri"/>
+                <a:sym typeface="Symbol"/>
+                <a:hlinkMouseOver r:id="rId4" tooltip="hover"/>
+              </a:defRPr>
+            </a:lvl1pPr>
+          </a:lstStyle>
+          <a:p>
+            <a:pPr>
+              <a:defRPr b="1"/>
+            </a:pPr>
+            <a:r>
+              <a:rPr u="sng">
+                <a:ln w="63500">
+                  <a:solidFill>
+                    <a:srgbClr val="008844"/>
+                  </a:solidFill>
+                </a:ln>
+                <a:noFill/>
+                <a:uFill>
+                  <a:pattFill prst="pct50">
+                    <a:fgClr>
+                      <a:srgbClr val="0033EE"/>
+                    </a:fgClr>
+                    <a:bgClr>
+                      <a:srgbClr val="FFDD00"/>
+                    </a:bgClr>
+                  </a:pattFill>
+                </a:uFill>
+              </a:rPr>
+              <a:t>WARP OUTLINE UNDERLINE</a:t>
+            </a:r>
+          </a:p>
+        </p:txBody>
+      </p:sp>
+      <p:sp>
+        <p:nvSpPr>
+          <p:cNvPr id="3" name="Inheritance 3"/>
+          <p:cNvSpPr txBox="1"/>
+          <p:nvPr/>
+        </p:nvSpPr>
+        <p:spPr>
+          <a:xfrm>
+            <a:off x="600000" y="3500000"/>
+            <a:ext cx="9000000" cy="1300000"/>
+          </a:xfrm>
+          <a:prstGeom prst="rect">
+            <a:avLst/>
+          </a:prstGeom>
+          <a:noFill/>
+        </p:spPr>
+        <p:txBody>
+          <a:bodyPr wrap="none" lIns="0" rIns="0" tIns="0" bIns="0"/>
+          <a:lstStyle>
+            <a:lvl1pPr>
+              <a:defRPr sz="4800" kumimoji="1" lang="ja-JP" altLang="en-US" kern="1200" cap="none" normalizeH="1" noProof="1" smtClean="0" smtId="17" bmk="sample">
+                <a:solidFill>
+                  <a:srgbClr val="D21D54"/>
+                </a:solidFill>
+                <a:latin typeface="Arial" panose="020B0604020202020204"/>
+                <a:cs typeface="Amiri"/>
+                <a:sym typeface="Symbol"/>
+                <a:hlinkMouseOver r:id="rId4" tooltip="hover"/>
+              </a:defRPr>
+            </a:lvl1pPr>
+          </a:lstStyle>
+          <a:p>
+            <a:pPr>
+              <a:defRPr b="1"/>
+            </a:pPr>
+            <a:r>
+              <a:rPr u="sng">
+                <a:ln w="63500">
+                  <a:solidFill>
+                    <a:srgbClr val="008844"/>
+                  </a:solidFill>
+                </a:ln>
+                <a:noFill/>
+                <a:uFill>
+                  <a:gradFill>
+                    <a:gsLst>
+                      <a:gs pos="0">
+                        <a:srgbClr val="00DDDD"/>
+                      </a:gs>
+                      <a:gs pos="100000">
+                        <a:srgbClr val="DD00DD"/>
+                      </a:gs>
+                    </a:gsLst>
+                    <a:lin ang="0"/>
+                  </a:gradFill>
+                </a:uFill>
+              </a:rPr>
+              <a:t>GRADIENT UNDERLINE</a:t>
+            </a:r>
+          </a:p>
+        </p:txBody>
+      </p:sp>
+      <p:sp>
+        <p:nvSpPr>
+          <p:cNvPr id="4" name="Inheritance 4"/>
+          <p:cNvSpPr txBox="1"/>
+          <p:nvPr/>
+        </p:nvSpPr>
+        <p:spPr>
+          <a:xfrm>
+            <a:off x="600000" y="5200000"/>
+            <a:ext cx="9000000" cy="1300000"/>
+          </a:xfrm>
+          <a:prstGeom prst="rect">
+            <a:avLst/>
+          </a:prstGeom>
+          <a:noFill/>
+        </p:spPr>
+        <p:txBody>
+          <a:bodyPr wrap="none" lIns="0" rIns="0" tIns="0" bIns="0">
+            <a:prstTxWarp prst="textArchUp">
+              <a:avLst/>
+            </a:prstTxWarp>
+          </a:bodyPr>
+          <a:lstStyle>
+            <a:lvl1pPr>
+              <a:defRPr sz="4800" kumimoji="1" lang="ja-JP" altLang="en-US" kern="1200" cap="none" normalizeH="1" noProof="1" smtClean="0" smtId="17" bmk="sample">
+                <a:solidFill>
+                  <a:srgbClr val="D21D54"/>
+                </a:solidFill>
+                <a:latin typeface="Arial" panose="020B0604020202020204"/>
+                <a:cs typeface="Amiri"/>
+                <a:sym typeface="Symbol"/>
+                <a:hlinkMouseOver r:id="rId4" tooltip="hover"/>
+              </a:defRPr>
+            </a:lvl1pPr>
+          </a:lstStyle>
+          <a:p>
+            <a:pPr>
+              <a:defRPr b="1"/>
+            </a:pPr>
+            <a:r>
+              <a:rPr u="sng">
+                <a:ln w="63500">
+                  <a:solidFill>
+                    <a:srgbClr val="008844"/>
+                  </a:solidFill>
+                </a:ln>
+                <a:noFill/>
+                <a:uFill>
+                  <a:gradFill>
+                    <a:gsLst>
+                      <a:gs pos="0">
+                        <a:srgbClr val="00DDDD"/>
+                      </a:gs>
+                      <a:gs pos="100000">
+                        <a:srgbClr val="DD00DD"/>
+                      </a:gs>
+                    </a:gsLst>
+                    <a:lin ang="0"/>
+                  </a:gradFill>
+                </a:uFill>
+              </a:rPr>
+              <a:t>WARP GRADIENT LINE</a:t>
+            </a:r>
+          </a:p>
+        </p:txBody>
+      </p:sp>
+    </p:spTree>
+  </p:cSld>
+</p:sld>
+</file>
+
+<file path=ppt/slides/slide3.xml><?xml version="1.0" encoding="utf-8"?>
+<p:sld xmlns:p="http://schemas.openxmlformats.org/presentationml/2006/main" xmlns:a="http://schemas.openxmlformats.org/drawingml/2006/main" xmlns:r="http://schemas.openxmlformats.org/officeDocument/2006/relationships">
+  <p:cSld>
+    <p:spTree>
+      <p:nvGrpSpPr>
+        <p:cNvPr id="1" name=""/>
+        <p:cNvGrpSpPr/>
+        <p:nvPr/>
+      </p:nvGrpSpPr>
+      <p:grpSpPr/>
+      <p:sp>
+        <p:nvSpPr>
+          <p:cNvPr id="2" name="Break 2400"/>
+          <p:cNvSpPr txBox="1"/>
+          <p:nvPr/>
+        </p:nvSpPr>
+        <p:spPr>
+          <a:xfrm>
+            <a:off x="600000" y="500000"/>
+            <a:ext cx="5000000" cy="2100000"/>
+          </a:xfrm>
+          <a:prstGeom prst="rect">
+            <a:avLst/>
+          </a:prstGeom>
+          <a:noFill/>
+        </p:spPr>
+        <p:txBody>
+          <a:bodyPr wrap="none" lIns="0" rIns="0" tIns="0" bIns="0"/>
+          <a:lstStyle/>
+          <a:p>
+            <a:r>
+              <a:rPr sz="2400"/>
+              <a:t>BEFORE</a:t>
+            </a:r>
+            <a:br>
+              <a:rPr sz="2400"/>
+            </a:br>
+            <a:r>
+              <a:rPr sz="2400"/>
+              <a:t>AFTER</a:t>
+            </a:r>
+            <a:endParaRPr sz="9600"/>
+          </a:p>
+        </p:txBody>
+      </p:sp>
+      <p:sp>
+        <p:nvSpPr>
+          <p:cNvPr id="3" name="Break 7200"/>
+          <p:cNvSpPr txBox="1"/>
+          <p:nvPr/>
+        </p:nvSpPr>
+        <p:spPr>
+          <a:xfrm>
+            <a:off x="6200000" y="500000"/>
+            <a:ext cx="5000000" cy="2100000"/>
+          </a:xfrm>
+          <a:prstGeom prst="rect">
+            <a:avLst/>
+          </a:prstGeom>
+          <a:noFill/>
+        </p:spPr>
+        <p:txBody>
+          <a:bodyPr wrap="none" lIns="0" rIns="0" tIns="0" bIns="0"/>
+          <a:lstStyle/>
+          <a:p>
+            <a:r>
+              <a:rPr sz="2400"/>
+              <a:t>BEFORE</a:t>
+            </a:r>
+            <a:br>
+              <a:rPr sz="7200"/>
+            </a:br>
+            <a:r>
+              <a:rPr sz="2400"/>
+              <a:t>AFTER</a:t>
+            </a:r>
+            <a:endParaRPr sz="9600"/>
+          </a:p>
+        </p:txBody>
+      </p:sp>
+      <p:graphicFrame>
+        <p:nvGraphicFramePr>
+          <p:cNvPr id="4" name="Table"/>
+          <p:cNvGraphicFramePr/>
+          <p:nvPr/>
+        </p:nvGraphicFramePr>
+        <p:xfrm>
+          <a:off x="600000" y="3600000"/>
+          <a:ext cx="10500000" cy="1800000"/>
+        </p:xfrm>
+        <a:graphic>
+          <a:graphicData uri="http://schemas.openxmlformats.org/drawingml/2006/table">
+            <a:tbl>
+              <a:tblPr/>
+              <a:tblGrid>
+                <a:gridCol w="10500000"/>
+              </a:tblGrid>
+              <a:tr h="1800000">
+                <a:tc>
+                  <a:txBody>
+                    <a:bodyPr/>
+                    <a:lstStyle>
+                      <a:defPPr>
+                        <a:defRPr lang="ja-JP" sz="2800">
+                          <a:solidFill>
+                            <a:srgbClr val="D21D54"/>
+                          </a:solidFill>
+                          <a:cs typeface="Amiri"/>
+                        </a:defRPr>
+                      </a:defPPr>
+                    </a:lstStyle>
+                    <a:p>
+                      <a:pPr>
+                        <a:defRPr b="1"/>
+                      </a:pPr>
+                      <a:r>
+                        <a:rPr/>
+                        <a:t>CELL INHERITS RED</a:t>
+                      </a:r>
+                      <a:fld id="{0FBB9679-570D-4509-9600-E07789CF24BB}" type="datetime">
+                        <a:rPr/>
+                        <a:t> FIELD RED</a:t>
+                      </a:fld>
+                    </a:p>
+                  </a:txBody>
+                  <a:tcPr/>
+                </a:tc>
+              </a:tr>
+            </a:tbl>
+          </a:graphicData>
+        </a:graphic>
+      </p:graphicFrame>
     </p:spTree>
   </p:cSld>
 </p:sld>

</xml_diff>